<commit_message>
chore: embed new Jira Scrum Board, Backlog, and ArgoCD environments screenshots into project docs and slides
</commit_message>
<xml_diff>
--- a/PPT Presentation.pptx
+++ b/PPT Presentation.pptx
@@ -7,6 +7,7 @@
   <p:sldIdLst>
     <p:sldId id="256" r:id="rId2"/>
     <p:sldId id="257" r:id="rId3"/>
+    <p:sldId id="266" r:id="rId16"/>
     <p:sldId id="258" r:id="rId4"/>
     <p:sldId id="259" r:id="rId5"/>
     <p:sldId id="260" r:id="rId6"/>
@@ -3362,6 +3363,129 @@
 </p:sld>
 </file>
 
+<file path=ppt/slides/slide11.xml><?xml version="1.0" encoding="utf-8"?>
+<p:sld xmlns:a="http://schemas.openxmlformats.org/drawingml/2006/main" xmlns:p="http://schemas.openxmlformats.org/presentationml/2006/main" xmlns:r="http://schemas.openxmlformats.org/officeDocument/2006/relationships">
+  <p:cSld>
+    <p:spTree>
+      <p:nvGrpSpPr>
+        <p:cNvPr id="1" name=""/>
+        <p:cNvGrpSpPr/>
+        <p:nvPr/>
+      </p:nvGrpSpPr>
+      <p:grpSpPr/>
+      <p:sp>
+        <p:nvSpPr>
+          <p:cNvPr id="2" name="Title 1"/>
+          <p:cNvSpPr>
+            <a:spLocks noGrp="1"/>
+          </p:cNvSpPr>
+          <p:nvPr>
+            <p:ph type="title"/>
+          </p:nvPr>
+        </p:nvSpPr>
+        <p:spPr/>
+        <p:txBody>
+          <a:bodyPr/>
+          <a:lstStyle/>
+          <a:p>
+            <a:r>
+              <a:t>Jira Board &amp; Agile Setup</a:t>
+            </a:r>
+          </a:p>
+        </p:txBody>
+      </p:sp>
+      <p:sp>
+        <p:nvSpPr>
+          <p:cNvPr id="3" name="TextBox 2"/>
+          <p:cNvSpPr txBox="1"/>
+          <p:nvPr/>
+        </p:nvSpPr>
+        <p:spPr>
+          <a:xfrm>
+            <a:off x="457200" y="1097280"/>
+            <a:ext cx="11274552" cy="457200"/>
+          </a:xfrm>
+          <a:prstGeom prst="rect">
+            <a:avLst/>
+          </a:prstGeom>
+          <a:noFill/>
+        </p:spPr>
+        <p:txBody>
+          <a:bodyPr wrap="square">
+            <a:spAutoFit/>
+          </a:bodyPr>
+          <a:lstStyle/>
+          <a:p>
+            <a:pPr>
+              <a:defRPr sz="1400">
+                <a:solidFill>
+                  <a:srgbClr val="3C3C3C"/>
+                </a:solidFill>
+                <a:latin typeface="Arial"/>
+              </a:defRPr>
+            </a:pPr>
+            <a:r>
+              <a:t>Configured an Agile Scrum board in Jira with a clear hierarchy of Epics, User Stories, Tasks, and Sub-tasks to manage SCM, CI/CD, GitOps, and Observability phases.</a:t>
+            </a:r>
+          </a:p>
+        </p:txBody>
+      </p:sp>
+      <p:pic>
+        <p:nvPicPr>
+          <p:cNvPr id="4" name="Picture 3" descr="board.png"/>
+          <p:cNvPicPr>
+            <a:picLocks noChangeAspect="1"/>
+          </p:cNvPicPr>
+          <p:nvPr/>
+        </p:nvPicPr>
+        <p:blipFill>
+          <a:blip r:embed="rId2"/>
+          <a:stretch>
+            <a:fillRect/>
+          </a:stretch>
+        </p:blipFill>
+        <p:spPr>
+          <a:xfrm>
+            <a:off x="548640" y="1645920"/>
+            <a:ext cx="5394960" cy="4114800"/>
+          </a:xfrm>
+          <a:prstGeom prst="rect">
+            <a:avLst/>
+          </a:prstGeom>
+        </p:spPr>
+      </p:pic>
+      <p:pic>
+        <p:nvPicPr>
+          <p:cNvPr id="5" name="Picture 4" descr="Backlog.png"/>
+          <p:cNvPicPr>
+            <a:picLocks noChangeAspect="1"/>
+          </p:cNvPicPr>
+          <p:nvPr/>
+        </p:nvPicPr>
+        <p:blipFill>
+          <a:blip r:embed="rId3"/>
+          <a:stretch>
+            <a:fillRect/>
+          </a:stretch>
+        </p:blipFill>
+        <p:spPr>
+          <a:xfrm>
+            <a:off x="6245352" y="1645920"/>
+            <a:ext cx="5394960" cy="4114800"/>
+          </a:xfrm>
+          <a:prstGeom prst="rect">
+            <a:avLst/>
+          </a:prstGeom>
+        </p:spPr>
+      </p:pic>
+    </p:spTree>
+  </p:cSld>
+  <p:clrMapOvr>
+    <a:masterClrMapping/>
+  </p:clrMapOvr>
+</p:sld>
+</file>
+
 <file path=ppt/slides/slide2.xml><?xml version="1.0" encoding="utf-8"?>
 <p:sld xmlns:a="http://schemas.openxmlformats.org/drawingml/2006/main" xmlns:r="http://schemas.openxmlformats.org/officeDocument/2006/relationships" xmlns:p="http://schemas.openxmlformats.org/presentationml/2006/main">
   <p:cSld>
@@ -4152,7 +4276,7 @@
       </p:sp>
       <p:pic>
         <p:nvPicPr>
-          <p:cNvPr id="4" name="Picture 3" descr="ArgoCd.png"/>
+          <p:cNvPr id="4" name="Picture 3" descr="image.png"/>
           <p:cNvPicPr>
             <a:picLocks noChangeAspect="1"/>
           </p:cNvPicPr>
@@ -4166,8 +4290,32 @@
         </p:blipFill>
         <p:spPr>
           <a:xfrm>
-            <a:off x="5029200" y="1371600"/>
-            <a:ext cx="6702552" cy="4572000"/>
+            <a:off x="548640" y="1645920"/>
+            <a:ext cx="5394960" cy="4114800"/>
+          </a:xfrm>
+          <a:prstGeom prst="rect">
+            <a:avLst/>
+          </a:prstGeom>
+        </p:spPr>
+      </p:pic>
+      <p:pic>
+        <p:nvPicPr>
+          <p:cNvPr id="5" name="Picture 4" descr="Environements.png"/>
+          <p:cNvPicPr>
+            <a:picLocks noChangeAspect="1"/>
+          </p:cNvPicPr>
+          <p:nvPr/>
+        </p:nvPicPr>
+        <p:blipFill>
+          <a:blip r:embed="rId3"/>
+          <a:stretch>
+            <a:fillRect/>
+          </a:stretch>
+        </p:blipFill>
+        <p:spPr>
+          <a:xfrm>
+            <a:off x="6245352" y="1645920"/>
+            <a:ext cx="5394960" cy="4114800"/>
           </a:xfrm>
           <a:prstGeom prst="rect">
             <a:avLst/>

</xml_diff>